<commit_message>
feat: enhance intake processing by adding attachment retrieval endpoint and improving error handling; update app structure to integrate intake services and streamline batch job processing
</commit_message>
<xml_diff>
--- a/presentation/SaifAlmaliki_Topic06_FAZAA_Design_Brief.pptx
+++ b/presentation/SaifAlmaliki_Topic06_FAZAA_Design_Brief.pptx
@@ -1429,17 +1429,76 @@
           <a:lstStyle/>
           <a:p>
             <a:r>
-              <a:rPr lang="en-US"/>
-              <a:t>Schedule dates are proposed delivery milestones based on the confirmed 22 October and 8 November 2026 deadlines. Meet-and-greet, semi-final consultation sessions, progress review and Demo Day are tentative. MVP requires working core, repository commit history, initial test-set results and a one-page update; top 10 continue. Progress review later requires held-out evidence, at least three documented failure modes and full disclosures.
-Risks: unclear Iraqi wording, wrong/ambiguous record matches, unavailable or conflicting policy, unsupported promises, secrets requests, injection, provider outages/limits, cost, interrupted runs, stale reviews and excessive scope. Current API startup marks interrupted running runs failed with a rerun message; it does not automatically resume checkpoints. Preserve saved results and demonstrate explicit reruns. Review rows use a locked current result and expected_updated_at to reject stale changes. Do not claim authentication/tenant isolation complete; this is a local synthetic workspace.
-Critical path: complete indexed policy evidence and safe drafting, then review-copy behavior and reliable evaluation. Defer weekly-report enhancements, advanced charts, supervisor administration and live dataset generation. Iraqi Arabic must be the default for user-facing labels/messages; English technical documentation and this brief remain available. API keys stay in backend .env excluded from GitHub, with only placeholder config in .env.example.
-MVP consultation: 20 minutes. Live demo should process an unexpected input, expose the evidence and next action, show uncertainty/failure handling and human review, and present measured results with limitations. A ready review packet is not a resolved customer issue.
-Repo: https://github.com/SaifAlmaliki/zaincash-customer-support-agent . References: README; docs/superpowers/specs/2026-10-07-support-pipeline-design.md; current dependency files, API routes, pipeline factory/graph and review service. Organizer: Agentic AI Challenge Next Steps.pdf, Resources.pdf, Free LLM API Access.pdf (11 October guide).
-Disclosure for this artifact: Saif supplied intent and approved the content. OpenCode, powered by openrouter/openai/gpt-6.1-sol-pro, assisted with repository analysis, wording, layout, native PowerPoint generation and artifact checks. Microsoft PowerPoint 16 via PowerShell COM creates editable objects and previews; Python standard-library ZIP/XML checks validate the PPTX. Context7 retrieved current LangGraph/OpenRouter documentation. Earlier proposal preparation disclosed OpenCode / openai/gpt-6-astra; preserve that attribution for earlier work. Other project coding assistants must be listed from actual use; none are invented here.
-These checks validate the presentation artifact, not model availability, application test results, production readiness or real-world customer impact.</a:t>
-            </a:r>
-            <a:endParaRPr lang="en-DE"/>
-          </a:p>
+              <a:t>Schedule dates are proposed delivery milestones based on the confirmed 22 October and 8 November 2026 deadlines. Meet-and-greet, semi-final consultation sessions, progress review and Demo Day are tentative. MVP requires working core, repository commit history, initial test-set results and a one-page update; top 10 continue. Progress review later requires held-out evidence, at least three documented failure modes and full disclosures.</a:t>
+            </a:r>
+          </a:p>
+          <a:p>
+            <a:r>
+              <a:t>Risks: unclear Iraqi wording, wrong/ambiguous record matches, unavailable or conflicting policy, unsupported promises, secrets requests, injection, provider outages/limits, cost, interrupted runs, stale reviews and excessive scope. Current API startup marks interrupted running runs failed with a rerun message; it does not automatically resume checkpoints. Preserve saved results and demonstrate explicit reruns. Review rows use a locked current result and expected_updated_at to reject stale changes. Do not claim authentication/tenant isolation complete; this is a local synthetic workspace.</a:t>
+            </a:r>
+          </a:p>
+          <a:p>
+            <a:r>
+              <a:t>Critical path: complete indexed policy evidence and safe drafting, then review-copy behavior and reliable evaluation. Defer weekly-report enhancements, advanced charts, supervisor administration and live dataset generation. Iraqi Arabic must be the default for user-facing labels/messages; English technical documentation and this brief remain available. API keys stay in backend .env excluded from GitHub, with only placeholder config in .env.example.</a:t>
+            </a:r>
+          </a:p>
+          <a:p>
+            <a:r>
+              <a:t>MVP consultation: 20 minutes. Live demo should process an unexpected input, expose the evidence and next action, show uncertainty/failure handling and human review, and present measured results with limitations. A ready review packet is not a resolved customer issue.</a:t>
+            </a:r>
+          </a:p>
+          <a:p>
+            <a:r>
+              <a:t>Repo: https://github.com/SaifAlmaliki/zaincash-customer-support-agent . References: README; docs/superpowers/specs/2026-10-07-support-pipeline-design.md; current dependency files, API routes, pipeline factory/graph and review service. Organizer: Agentic AI Challenge Next Steps.pdf, Resources.pdf, Free LLM API Access.pdf (11 October guide).</a:t>
+            </a:r>
+          </a:p>
+          <a:p>
+            <a:r>
+              <a:t>Disclosure for this artifact: Saif supplied intent and approved the content. OpenCode, powered by openrouter/openai/gpt-6.1-sol-pro, assisted with repository analysis, wording, layout, native PowerPoint generation and artifact checks. Microsoft PowerPoint 16 via PowerShell COM creates editable objects and previews; Python standard-library ZIP/XML checks validate the PPTX. Context7 retrieved current LangGraph/OpenRouter documentation. Earlier proposal preparation disclosed OpenCode / openai/gpt-6-astra; preserve that attribution for earlier work. Other project coding assistants must be listed from actual use; none are invented here.</a:t>
+            </a:r>
+          </a:p>
+          <a:p>
+            <a:r>
+              <a:t>These checks validate the presentation artifact, not model availability, application test results, production readiness or real-world customer impact.</a:t>
+            </a:r>
+          </a:p>
+          <a:p/>
+          <a:p>
+            <a:r>
+              <a:t>EVALUATION PLAN added 18 October 2026 (design spec section 7). This is the measurement plan, not a result.</a:t>
+            </a:r>
+          </a:p>
+          <a:p>
+            <a:r>
+              <a:t>A good result, on judge input and on the held-out set: the category, priority and team match the label, or the ticket is escalated with a reason when confidence is low; every extracted amount, date, phone and reference appears in the ticket (a value predicted where gold is null is a hallucination); the draft cites a policy passage, uses only known numbers, and does not ask for an OTP, PIN or password; a reviewer approves, edits or rejects. There is no send path.</a:t>
+            </a:r>
+          </a:p>
+          <a:p>
+            <a:r>
+              <a:t>Protocol: about 300 synthetic Iraqi-dialect tickets, stratified across 12 categories. Labels come from code; a model writes the text; code checks that every gold value appears in the text. Seed-42 split, 200 dev and 100 test. Commit test.sha256 before tuning prompts, thresholds or wording. Tune on dev only, freeze, then run the test set once for jev, gemini and cascade and commit those three results.</a:t>
+            </a:r>
+          </a:p>
+          <a:p>
+            <a:r>
+              <a:t>Also measured, and named in the speaker script if the slide is tight: per-flag precision as well as fraud recall; reliability diagram and expected calibration error; an LLM judge for correctness, tone, dialect and actionability beside the 30 human ratings; throughput, p50/p95 latency and cost per ticket; separate scores for Arabizi, mixed language, multi-issue, missing details and prompt injection.</a:t>
+            </a:r>
+          </a:p>
+          <a:p>
+            <a:r>
+              <a:t>Known bias: Gemini helps generate the tickets and may also judge drafts. Human ratings are the check. Say so. pytest and ruff guard the rules, lookup and draft checks; they are not the held-out score.</a:t>
+            </a:r>
+          </a:p>
+          <a:p>
+            <a:r>
+              <a:t>As of this brief, Plan 2 held-out evaluation has not been run. The five-ticket smoke runs and the 17 October RAG demo are not this test set. The 6–8 November milestone is when the first held-out numbers are committed.</a:t>
+            </a:r>
+          </a:p>
+          <a:p>
+            <a:r>
+              <a:t>Risks, the week-by-week plan and the GitHub link were already on this slide. The link is https://github.com/SaifAlmaliki/zaincash-customer-support-agent</a:t>
+            </a:r>
+          </a:p>
+          <a:p/>
         </p:txBody>
       </p:sp>
       <p:sp>
@@ -19319,7 +19378,7 @@
                 </a:solidFill>
                 <a:latin typeface="Arial" panose="020B0604020202020204" pitchFamily="34" charset="0"/>
               </a:rPr>
-              <a:t>Risks and the road to the MVP</a:t>
+              <a:t>How we test, what can go wrong, and the plan</a:t>
             </a:r>
             <a:endParaRPr lang="en-DE" sz="3200" b="1">
               <a:solidFill>
@@ -19431,8 +19490,8 @@
         </p:nvSpPr>
         <p:spPr>
           <a:xfrm>
-            <a:off x="508000" y="1778000"/>
-            <a:ext cx="7277100" cy="5765800"/>
+            <a:off x="512064" y="4663440"/>
+            <a:ext cx="7278624" cy="2980944"/>
           </a:xfrm>
           <a:prstGeom prst="rect">
             <a:avLst/>
@@ -19485,8 +19544,8 @@
         </p:nvSpPr>
         <p:spPr>
           <a:xfrm>
-            <a:off x="736600" y="1968500"/>
-            <a:ext cx="6819900" cy="279400"/>
+            <a:off x="713232" y="4736592"/>
+            <a:ext cx="6858000" cy="219456"/>
           </a:xfrm>
           <a:prstGeom prst="rect">
             <a:avLst/>
@@ -19494,17 +19553,19 @@
           <a:noFill/>
         </p:spPr>
         <p:txBody>
-          <a:bodyPr vert="horz" wrap="square" lIns="0" tIns="0" rIns="0" bIns="0" rtlCol="0" anchor="t">
+          <a:bodyPr vert="horz" wrap="square" lIns="36576" tIns="0" rIns="36576" bIns="0" rtlCol="0" anchor="t">
             <a:noAutofit/>
           </a:bodyPr>
           <a:lstStyle/>
           <a:p>
             <a:r>
-              <a:rPr lang="en-US" sz="1400" b="1">
+              <a:rPr lang="en-US" sz="1200" b="1">
                 <a:solidFill>
                   <a:srgbClr val="087E83"/>
                 </a:solidFill>
                 <a:latin typeface="Arial" panose="020B0604020202020204" pitchFamily="34" charset="0"/>
+                <a:ea typeface="Arial"/>
+                <a:cs typeface="Arial"/>
               </a:rPr>
               <a:t>WHAT COULD GO WRONG / OUR RESPONSE</a:t>
             </a:r>
@@ -19531,8 +19592,8 @@
         </p:nvSpPr>
         <p:spPr>
           <a:xfrm>
-            <a:off x="736600" y="2374900"/>
-            <a:ext cx="6819900" cy="317500"/>
+            <a:off x="713232" y="4992624"/>
+            <a:ext cx="6858000" cy="201168"/>
           </a:xfrm>
           <a:prstGeom prst="rect">
             <a:avLst/>
@@ -19540,17 +19601,19 @@
           <a:noFill/>
         </p:spPr>
         <p:txBody>
-          <a:bodyPr vert="horz" wrap="square" lIns="0" tIns="0" rIns="0" bIns="0" rtlCol="0" anchor="t">
+          <a:bodyPr vert="horz" wrap="square" lIns="36576" tIns="0" rIns="36576" bIns="0" rtlCol="0" anchor="t">
             <a:noAutofit/>
           </a:bodyPr>
           <a:lstStyle/>
           <a:p>
             <a:r>
-              <a:rPr lang="en-US" b="1">
+              <a:rPr lang="en-US" b="1" sz="1300">
                 <a:solidFill>
                   <a:srgbClr val="203947"/>
                 </a:solidFill>
                 <a:latin typeface="Arial" panose="020B0604020202020204" pitchFamily="34" charset="0"/>
+                <a:ea typeface="Arial"/>
+                <a:cs typeface="Arial"/>
               </a:rPr>
               <a:t>Dialect / disagreement</a:t>
             </a:r>
@@ -19577,8 +19640,8 @@
         </p:nvSpPr>
         <p:spPr>
           <a:xfrm>
-            <a:off x="736600" y="2755900"/>
-            <a:ext cx="6819900" cy="533400"/>
+            <a:off x="713232" y="5193792"/>
+            <a:ext cx="6858000" cy="274320"/>
           </a:xfrm>
           <a:prstGeom prst="rect">
             <a:avLst/>
@@ -19586,17 +19649,19 @@
           <a:noFill/>
         </p:spPr>
         <p:txBody>
-          <a:bodyPr vert="horz" wrap="square" lIns="0" tIns="0" rIns="0" bIns="0" rtlCol="0" anchor="t">
+          <a:bodyPr vert="horz" wrap="square" lIns="36576" tIns="0" rIns="36576" bIns="0" rtlCol="0" anchor="t">
             <a:noAutofit/>
           </a:bodyPr>
           <a:lstStyle/>
           <a:p>
             <a:r>
-              <a:rPr lang="en-US" sz="1700">
+              <a:rPr lang="en-US" sz="1200">
                 <a:solidFill>
                   <a:srgbClr val="536873"/>
                 </a:solidFill>
                 <a:latin typeface="Arial" panose="020B0604020202020204" pitchFamily="34" charset="0"/>
+                <a:ea typeface="Arial"/>
+                <a:cs typeface="Arial"/>
               </a:rPr>
               <a:t>Validate mixed-language cases; escalate unresolved uncertainty.</a:t>
             </a:r>
@@ -19623,8 +19688,8 @@
         </p:nvSpPr>
         <p:spPr>
           <a:xfrm>
-            <a:off x="736600" y="3378200"/>
-            <a:ext cx="6819900" cy="317500"/>
+            <a:off x="713232" y="5504688"/>
+            <a:ext cx="6858000" cy="201168"/>
           </a:xfrm>
           <a:prstGeom prst="rect">
             <a:avLst/>
@@ -19632,17 +19697,19 @@
           <a:noFill/>
         </p:spPr>
         <p:txBody>
-          <a:bodyPr vert="horz" wrap="square" lIns="0" tIns="0" rIns="0" bIns="0" rtlCol="0" anchor="t">
+          <a:bodyPr vert="horz" wrap="square" lIns="36576" tIns="0" rIns="36576" bIns="0" rtlCol="0" anchor="t">
             <a:noAutofit/>
           </a:bodyPr>
           <a:lstStyle/>
           <a:p>
             <a:r>
-              <a:rPr lang="en-US" b="1">
+              <a:rPr lang="en-US" b="1" sz="1300">
                 <a:solidFill>
                   <a:srgbClr val="203947"/>
                 </a:solidFill>
                 <a:latin typeface="Arial" panose="020B0604020202020204" pitchFamily="34" charset="0"/>
+                <a:ea typeface="Arial"/>
+                <a:cs typeface="Arial"/>
               </a:rPr>
               <a:t>Wrong match / missing policy</a:t>
             </a:r>
@@ -19669,8 +19736,8 @@
         </p:nvSpPr>
         <p:spPr>
           <a:xfrm>
-            <a:off x="736600" y="3759200"/>
-            <a:ext cx="6819900" cy="533400"/>
+            <a:off x="713232" y="5705856"/>
+            <a:ext cx="6858000" cy="274320"/>
           </a:xfrm>
           <a:prstGeom prst="rect">
             <a:avLst/>
@@ -19678,17 +19745,19 @@
           <a:noFill/>
         </p:spPr>
         <p:txBody>
-          <a:bodyPr vert="horz" wrap="square" lIns="0" tIns="0" rIns="0" bIns="0" rtlCol="0" anchor="t">
+          <a:bodyPr vert="horz" wrap="square" lIns="36576" tIns="0" rIns="36576" bIns="0" rtlCol="0" anchor="t">
             <a:noAutofit/>
           </a:bodyPr>
           <a:lstStyle/>
           <a:p>
             <a:r>
-              <a:rPr lang="en-US" sz="1700">
+              <a:rPr lang="en-US" sz="1200">
                 <a:solidFill>
                   <a:srgbClr val="536873"/>
                 </a:solidFill>
                 <a:latin typeface="Arial" panose="020B0604020202020204" pitchFamily="34" charset="0"/>
+                <a:ea typeface="Arial"/>
+                <a:cs typeface="Arial"/>
               </a:rPr>
               <a:t>Preserve ambiguity; show unavailable evidence; never invent facts.</a:t>
             </a:r>
@@ -19715,8 +19784,8 @@
         </p:nvSpPr>
         <p:spPr>
           <a:xfrm>
-            <a:off x="736600" y="4381500"/>
-            <a:ext cx="6819900" cy="317500"/>
+            <a:off x="713232" y="6016752"/>
+            <a:ext cx="6858000" cy="201168"/>
           </a:xfrm>
           <a:prstGeom prst="rect">
             <a:avLst/>
@@ -19724,17 +19793,19 @@
           <a:noFill/>
         </p:spPr>
         <p:txBody>
-          <a:bodyPr vert="horz" wrap="square" lIns="0" tIns="0" rIns="0" bIns="0" rtlCol="0" anchor="t">
+          <a:bodyPr vert="horz" wrap="square" lIns="36576" tIns="0" rIns="36576" bIns="0" rtlCol="0" anchor="t">
             <a:noAutofit/>
           </a:bodyPr>
           <a:lstStyle/>
           <a:p>
             <a:r>
-              <a:rPr lang="en-US" b="1">
+              <a:rPr lang="en-US" b="1" sz="1300">
                 <a:solidFill>
                   <a:srgbClr val="203947"/>
                 </a:solidFill>
                 <a:latin typeface="Arial" panose="020B0604020202020204" pitchFamily="34" charset="0"/>
+                <a:ea typeface="Arial"/>
+                <a:cs typeface="Arial"/>
               </a:rPr>
               <a:t>Unsafe draft</a:t>
             </a:r>
@@ -19761,8 +19832,8 @@
         </p:nvSpPr>
         <p:spPr>
           <a:xfrm>
-            <a:off x="736600" y="4762500"/>
-            <a:ext cx="6819900" cy="533400"/>
+            <a:off x="713232" y="6217920"/>
+            <a:ext cx="6858000" cy="274320"/>
           </a:xfrm>
           <a:prstGeom prst="rect">
             <a:avLst/>
@@ -19770,17 +19841,19 @@
           <a:noFill/>
         </p:spPr>
         <p:txBody>
-          <a:bodyPr vert="horz" wrap="square" lIns="0" tIns="0" rIns="0" bIns="0" rtlCol="0" anchor="t">
+          <a:bodyPr vert="horz" wrap="square" lIns="36576" tIns="0" rIns="36576" bIns="0" rtlCol="0" anchor="t">
             <a:noAutofit/>
           </a:bodyPr>
           <a:lstStyle/>
           <a:p>
             <a:r>
-              <a:rPr lang="en-US" sz="1700">
+              <a:rPr lang="en-US" sz="1200">
                 <a:solidFill>
                   <a:srgbClr val="536873"/>
                 </a:solidFill>
                 <a:latin typeface="Arial" panose="020B0604020202020204" pitchFamily="34" charset="0"/>
+                <a:ea typeface="Arial"/>
+                <a:cs typeface="Arial"/>
               </a:rPr>
               <a:t>Citation / number / credential checks plus mandatory human review.</a:t>
             </a:r>
@@ -19807,8 +19880,8 @@
         </p:nvSpPr>
         <p:spPr>
           <a:xfrm>
-            <a:off x="736600" y="5384800"/>
-            <a:ext cx="6819900" cy="317500"/>
+            <a:off x="713232" y="6528816"/>
+            <a:ext cx="6858000" cy="201168"/>
           </a:xfrm>
           <a:prstGeom prst="rect">
             <a:avLst/>
@@ -19816,17 +19889,19 @@
           <a:noFill/>
         </p:spPr>
         <p:txBody>
-          <a:bodyPr vert="horz" wrap="square" lIns="0" tIns="0" rIns="0" bIns="0" rtlCol="0" anchor="t">
+          <a:bodyPr vert="horz" wrap="square" lIns="36576" tIns="0" rIns="36576" bIns="0" rtlCol="0" anchor="t">
             <a:noAutofit/>
           </a:bodyPr>
           <a:lstStyle/>
           <a:p>
             <a:r>
-              <a:rPr lang="en-US" b="1">
+              <a:rPr lang="en-US" b="1" sz="1300">
                 <a:solidFill>
                   <a:srgbClr val="203947"/>
                 </a:solidFill>
                 <a:latin typeface="Arial" panose="020B0604020202020204" pitchFamily="34" charset="0"/>
+                <a:ea typeface="Arial"/>
+                <a:cs typeface="Arial"/>
               </a:rPr>
               <a:t>Outage / cost / restart</a:t>
             </a:r>
@@ -19853,8 +19928,8 @@
         </p:nvSpPr>
         <p:spPr>
           <a:xfrm>
-            <a:off x="736600" y="5765800"/>
-            <a:ext cx="6819900" cy="533400"/>
+            <a:off x="713232" y="6729983"/>
+            <a:ext cx="6858000" cy="274320"/>
           </a:xfrm>
           <a:prstGeom prst="rect">
             <a:avLst/>
@@ -19862,17 +19937,19 @@
           <a:noFill/>
         </p:spPr>
         <p:txBody>
-          <a:bodyPr vert="horz" wrap="square" lIns="0" tIns="0" rIns="0" bIns="0" rtlCol="0" anchor="t">
+          <a:bodyPr vert="horz" wrap="square" lIns="36576" tIns="0" rIns="36576" bIns="0" rtlCol="0" anchor="t">
             <a:noAutofit/>
           </a:bodyPr>
           <a:lstStyle/>
           <a:p>
             <a:r>
-              <a:rPr lang="en-US" sz="1700">
+              <a:rPr lang="en-US" sz="1200">
                 <a:solidFill>
                   <a:srgbClr val="536873"/>
                 </a:solidFill>
                 <a:latin typeface="Arial" panose="020B0604020202020204" pitchFamily="34" charset="0"/>
+                <a:ea typeface="Arial"/>
+                <a:cs typeface="Arial"/>
               </a:rPr>
               <a:t>Bounded retries; budget reserve; visibly fail interrupted runs and rerun.</a:t>
             </a:r>
@@ -19899,8 +19976,8 @@
         </p:nvSpPr>
         <p:spPr>
           <a:xfrm>
-            <a:off x="736600" y="6388100"/>
-            <a:ext cx="6819900" cy="317500"/>
+            <a:off x="713232" y="7040880"/>
+            <a:ext cx="6858000" cy="201168"/>
           </a:xfrm>
           <a:prstGeom prst="rect">
             <a:avLst/>
@@ -19908,17 +19985,19 @@
           <a:noFill/>
         </p:spPr>
         <p:txBody>
-          <a:bodyPr vert="horz" wrap="square" lIns="0" tIns="0" rIns="0" bIns="0" rtlCol="0" anchor="t">
+          <a:bodyPr vert="horz" wrap="square" lIns="36576" tIns="0" rIns="36576" bIns="0" rtlCol="0" anchor="t">
             <a:noAutofit/>
           </a:bodyPr>
           <a:lstStyle/>
           <a:p>
             <a:r>
-              <a:rPr lang="en-US" b="1">
+              <a:rPr lang="en-US" b="1" sz="1300">
                 <a:solidFill>
                   <a:srgbClr val="203947"/>
                 </a:solidFill>
                 <a:latin typeface="Arial" panose="020B0604020202020204" pitchFamily="34" charset="0"/>
+                <a:ea typeface="Arial"/>
+                <a:cs typeface="Arial"/>
               </a:rPr>
               <a:t>Review conflict / scope</a:t>
             </a:r>
@@ -19945,8 +20024,8 @@
         </p:nvSpPr>
         <p:spPr>
           <a:xfrm>
-            <a:off x="736600" y="6769100"/>
-            <a:ext cx="6819900" cy="533400"/>
+            <a:off x="713232" y="7242048"/>
+            <a:ext cx="6858000" cy="274320"/>
           </a:xfrm>
           <a:prstGeom prst="rect">
             <a:avLst/>
@@ -19954,17 +20033,19 @@
           <a:noFill/>
         </p:spPr>
         <p:txBody>
-          <a:bodyPr vert="horz" wrap="square" lIns="0" tIns="0" rIns="0" bIns="0" rtlCol="0" anchor="t">
+          <a:bodyPr vert="horz" wrap="square" lIns="36576" tIns="0" rIns="36576" bIns="0" rtlCol="0" anchor="t">
             <a:noAutofit/>
           </a:bodyPr>
           <a:lstStyle/>
           <a:p>
             <a:r>
-              <a:rPr lang="en-US" sz="1700">
+              <a:rPr lang="en-US" sz="1200">
                 <a:solidFill>
                   <a:srgbClr val="536873"/>
                 </a:solidFill>
                 <a:latin typeface="Arial" panose="020B0604020202020204" pitchFamily="34" charset="0"/>
+                <a:ea typeface="Arial"/>
+                <a:cs typeface="Arial"/>
               </a:rPr>
               <a:t>Reject stale updates; prioritize the core; defer advanced analytics.</a:t>
             </a:r>
@@ -19991,8 +20072,8 @@
         </p:nvSpPr>
         <p:spPr>
           <a:xfrm>
-            <a:off x="8102600" y="1778000"/>
-            <a:ext cx="7645400" cy="5765800"/>
+            <a:off x="8101583" y="4663440"/>
+            <a:ext cx="7644383" cy="2980944"/>
           </a:xfrm>
           <a:prstGeom prst="rect">
             <a:avLst/>
@@ -20045,8 +20126,8 @@
         </p:nvSpPr>
         <p:spPr>
           <a:xfrm>
-            <a:off x="8331200" y="1968500"/>
-            <a:ext cx="7188200" cy="279400"/>
+            <a:off x="8302752" y="4736592"/>
+            <a:ext cx="7223760" cy="219456"/>
           </a:xfrm>
           <a:prstGeom prst="rect">
             <a:avLst/>
@@ -20054,17 +20135,19 @@
           <a:noFill/>
         </p:spPr>
         <p:txBody>
-          <a:bodyPr vert="horz" wrap="square" lIns="0" tIns="0" rIns="0" bIns="0" rtlCol="0" anchor="t">
+          <a:bodyPr vert="horz" wrap="square" lIns="36576" tIns="0" rIns="36576" bIns="0" rtlCol="0" anchor="t">
             <a:noAutofit/>
           </a:bodyPr>
           <a:lstStyle/>
           <a:p>
             <a:r>
-              <a:rPr lang="en-US" sz="1400" b="1">
+              <a:rPr lang="en-US" sz="1200" b="1">
                 <a:solidFill>
                   <a:srgbClr val="087E83"/>
                 </a:solidFill>
                 <a:latin typeface="Arial" panose="020B0604020202020204" pitchFamily="34" charset="0"/>
+                <a:ea typeface="Arial"/>
+                <a:cs typeface="Arial"/>
               </a:rPr>
               <a:t>WEEK-BY-WEEK DELIVERY / EXIT MILESTONE</a:t>
             </a:r>
@@ -20091,8 +20174,8 @@
         </p:nvSpPr>
         <p:spPr>
           <a:xfrm>
-            <a:off x="8331200" y="2400300"/>
-            <a:ext cx="1778000" cy="406400"/>
+            <a:off x="8302752" y="5029200"/>
+            <a:ext cx="1572768" cy="310896"/>
           </a:xfrm>
           <a:prstGeom prst="rect">
             <a:avLst/>
@@ -20159,8 +20242,8 @@
         </p:nvSpPr>
         <p:spPr>
           <a:xfrm>
-            <a:off x="8432800" y="2489200"/>
-            <a:ext cx="1574800" cy="266700"/>
+            <a:off x="8339327" y="5056632"/>
+            <a:ext cx="1499616" cy="256032"/>
           </a:xfrm>
           <a:prstGeom prst="rect">
             <a:avLst/>
@@ -20168,18 +20251,20 @@
           <a:noFill/>
         </p:spPr>
         <p:txBody>
-          <a:bodyPr vert="horz" wrap="square" lIns="0" tIns="0" rIns="0" bIns="0" rtlCol="0" anchor="t">
+          <a:bodyPr vert="horz" wrap="square" lIns="36576" tIns="0" rIns="36576" bIns="0" rtlCol="0" anchor="t">
             <a:noAutofit/>
           </a:bodyPr>
           <a:lstStyle/>
           <a:p>
             <a:pPr algn="ctr"/>
             <a:r>
-              <a:rPr lang="en-US" sz="1400" b="1">
+              <a:rPr lang="en-US" sz="1100" b="1">
                 <a:solidFill>
                   <a:srgbClr val="087E83"/>
                 </a:solidFill>
                 <a:latin typeface="Arial" panose="020B0604020202020204" pitchFamily="34" charset="0"/>
+                <a:ea typeface="Arial"/>
+                <a:cs typeface="Arial"/>
               </a:rPr>
               <a:t>17-22 OCT</a:t>
             </a:r>
@@ -20206,8 +20291,8 @@
         </p:nvSpPr>
         <p:spPr>
           <a:xfrm>
-            <a:off x="10325100" y="2400300"/>
-            <a:ext cx="5194300" cy="342900"/>
+            <a:off x="10040112" y="5010912"/>
+            <a:ext cx="5468112" cy="237744"/>
           </a:xfrm>
           <a:prstGeom prst="rect">
             <a:avLst/>
@@ -20215,17 +20300,19 @@
           <a:noFill/>
         </p:spPr>
         <p:txBody>
-          <a:bodyPr vert="horz" wrap="square" lIns="0" tIns="0" rIns="0" bIns="0" rtlCol="0" anchor="t">
+          <a:bodyPr vert="horz" wrap="square" lIns="36576" tIns="0" rIns="36576" bIns="0" rtlCol="0" anchor="t">
             <a:noAutofit/>
           </a:bodyPr>
           <a:lstStyle/>
           <a:p>
             <a:r>
-              <a:rPr lang="en-US" b="1">
+              <a:rPr lang="en-US" b="1" sz="1300">
                 <a:solidFill>
                   <a:srgbClr val="203947"/>
                 </a:solidFill>
                 <a:latin typeface="Arial" panose="020B0604020202020204" pitchFamily="34" charset="0"/>
+                <a:ea typeface="Arial"/>
+                <a:cs typeface="Arial"/>
               </a:rPr>
               <a:t>Design + evaluation foundation</a:t>
             </a:r>
@@ -20252,8 +20339,8 @@
         </p:nvSpPr>
         <p:spPr>
           <a:xfrm>
-            <a:off x="10325100" y="2819400"/>
-            <a:ext cx="5194300" cy="800100"/>
+            <a:off x="10040112" y="5266944"/>
+            <a:ext cx="5468112" cy="365760"/>
           </a:xfrm>
           <a:prstGeom prst="rect">
             <a:avLst/>
@@ -20261,17 +20348,19 @@
           <a:noFill/>
         </p:spPr>
         <p:txBody>
-          <a:bodyPr vert="horz" wrap="square" lIns="0" tIns="0" rIns="0" bIns="0" rtlCol="0" anchor="t">
+          <a:bodyPr vert="horz" wrap="square" lIns="36576" tIns="0" rIns="36576" bIns="0" rtlCol="0" anchor="t">
             <a:noAutofit/>
           </a:bodyPr>
           <a:lstStyle/>
           <a:p>
             <a:r>
-              <a:rPr lang="en-US" sz="1700">
+              <a:rPr lang="en-US" sz="1200">
                 <a:solidFill>
                   <a:srgbClr val="536873"/>
                 </a:solidFill>
                 <a:latin typeface="Arial" panose="020B0604020202020204" pitchFamily="34" charset="0"/>
+                <a:ea typeface="Arial"/>
+                <a:cs typeface="Arial"/>
               </a:rPr>
               <a:t>Submit brief; check model access; define metrics and protected scenario split.</a:t>
             </a:r>
@@ -20298,8 +20387,8 @@
         </p:nvSpPr>
         <p:spPr>
           <a:xfrm>
-            <a:off x="8331200" y="3644900"/>
-            <a:ext cx="1778000" cy="406400"/>
+            <a:off x="8302752" y="5687568"/>
+            <a:ext cx="1572768" cy="310896"/>
           </a:xfrm>
           <a:prstGeom prst="rect">
             <a:avLst/>
@@ -20366,8 +20455,8 @@
         </p:nvSpPr>
         <p:spPr>
           <a:xfrm>
-            <a:off x="8432800" y="3733800"/>
-            <a:ext cx="1574800" cy="266700"/>
+            <a:off x="8339327" y="5715000"/>
+            <a:ext cx="1499616" cy="256032"/>
           </a:xfrm>
           <a:prstGeom prst="rect">
             <a:avLst/>
@@ -20375,18 +20464,20 @@
           <a:noFill/>
         </p:spPr>
         <p:txBody>
-          <a:bodyPr vert="horz" wrap="square" lIns="0" tIns="0" rIns="0" bIns="0" rtlCol="0" anchor="t">
+          <a:bodyPr vert="horz" wrap="square" lIns="36576" tIns="0" rIns="36576" bIns="0" rtlCol="0" anchor="t">
             <a:noAutofit/>
           </a:bodyPr>
           <a:lstStyle/>
           <a:p>
             <a:pPr algn="ctr"/>
             <a:r>
-              <a:rPr lang="en-US" sz="1400" b="1">
+              <a:rPr lang="en-US" sz="1100" b="1">
                 <a:solidFill>
                   <a:srgbClr val="087E83"/>
                 </a:solidFill>
                 <a:latin typeface="Arial" panose="020B0604020202020204" pitchFamily="34" charset="0"/>
+                <a:ea typeface="Arial"/>
+                <a:cs typeface="Arial"/>
               </a:rPr>
               <a:t>23-29 OCT</a:t>
             </a:r>
@@ -20413,8 +20504,8 @@
         </p:nvSpPr>
         <p:spPr>
           <a:xfrm>
-            <a:off x="10325100" y="3644900"/>
-            <a:ext cx="5194300" cy="342900"/>
+            <a:off x="10040112" y="5669280"/>
+            <a:ext cx="5468112" cy="237744"/>
           </a:xfrm>
           <a:prstGeom prst="rect">
             <a:avLst/>
@@ -20422,17 +20513,19 @@
           <a:noFill/>
         </p:spPr>
         <p:txBody>
-          <a:bodyPr vert="horz" wrap="square" lIns="0" tIns="0" rIns="0" bIns="0" rtlCol="0" anchor="t">
+          <a:bodyPr vert="horz" wrap="square" lIns="36576" tIns="0" rIns="36576" bIns="0" rtlCol="0" anchor="t">
             <a:noAutofit/>
           </a:bodyPr>
           <a:lstStyle/>
           <a:p>
             <a:r>
-              <a:rPr lang="en-US" b="1">
+              <a:rPr lang="en-US" b="1" sz="1300">
                 <a:solidFill>
                   <a:srgbClr val="203947"/>
                 </a:solidFill>
                 <a:latin typeface="Arial" panose="020B0604020202020204" pitchFamily="34" charset="0"/>
+                <a:ea typeface="Arial"/>
+                <a:cs typeface="Arial"/>
               </a:rPr>
               <a:t>Evidence-backed vertical slice</a:t>
             </a:r>
@@ -20459,8 +20552,8 @@
         </p:nvSpPr>
         <p:spPr>
           <a:xfrm>
-            <a:off x="10325100" y="4064000"/>
-            <a:ext cx="5194300" cy="800100"/>
+            <a:off x="10040112" y="5925312"/>
+            <a:ext cx="5468112" cy="365760"/>
           </a:xfrm>
           <a:prstGeom prst="rect">
             <a:avLst/>
@@ -20468,17 +20561,19 @@
           <a:noFill/>
         </p:spPr>
         <p:txBody>
-          <a:bodyPr vert="horz" wrap="square" lIns="0" tIns="0" rIns="0" bIns="0" rtlCol="0" anchor="t">
+          <a:bodyPr vert="horz" wrap="square" lIns="36576" tIns="0" rIns="36576" bIns="0" rtlCol="0" anchor="t">
             <a:noAutofit/>
           </a:bodyPr>
           <a:lstStyle/>
           <a:p>
             <a:r>
-              <a:rPr lang="en-US" sz="1700">
+              <a:rPr lang="en-US" sz="1200">
                 <a:solidFill>
                   <a:srgbClr val="536873"/>
                 </a:solidFill>
                 <a:latin typeface="Arial" panose="020B0604020202020204" pitchFamily="34" charset="0"/>
+                <a:ea typeface="Arial"/>
+                <a:cs typeface="Arial"/>
               </a:rPr>
               <a:t>Policy indexing + Iraqi Arabic drafting; 20 tickets complete the review flow.</a:t>
             </a:r>
@@ -20505,8 +20600,8 @@
         </p:nvSpPr>
         <p:spPr>
           <a:xfrm>
-            <a:off x="8331200" y="4889500"/>
-            <a:ext cx="1778000" cy="406400"/>
+            <a:off x="8302752" y="6345936"/>
+            <a:ext cx="1572768" cy="310896"/>
           </a:xfrm>
           <a:prstGeom prst="rect">
             <a:avLst/>
@@ -20573,8 +20668,8 @@
         </p:nvSpPr>
         <p:spPr>
           <a:xfrm>
-            <a:off x="8432800" y="4978400"/>
-            <a:ext cx="1574800" cy="266700"/>
+            <a:off x="8339327" y="6373368"/>
+            <a:ext cx="1499616" cy="256032"/>
           </a:xfrm>
           <a:prstGeom prst="rect">
             <a:avLst/>
@@ -20582,18 +20677,20 @@
           <a:noFill/>
         </p:spPr>
         <p:txBody>
-          <a:bodyPr vert="horz" wrap="square" lIns="0" tIns="0" rIns="0" bIns="0" rtlCol="0" anchor="t">
+          <a:bodyPr vert="horz" wrap="square" lIns="36576" tIns="0" rIns="36576" bIns="0" rtlCol="0" anchor="t">
             <a:noAutofit/>
           </a:bodyPr>
           <a:lstStyle/>
           <a:p>
             <a:pPr algn="ctr"/>
             <a:r>
-              <a:rPr lang="en-US" sz="1400" b="1">
+              <a:rPr lang="en-US" sz="1100" b="1">
                 <a:solidFill>
                   <a:srgbClr val="087E83"/>
                 </a:solidFill>
                 <a:latin typeface="Arial" panose="020B0604020202020204" pitchFamily="34" charset="0"/>
+                <a:ea typeface="Arial"/>
+                <a:cs typeface="Arial"/>
               </a:rPr>
               <a:t>30 OCT-5 NOV</a:t>
             </a:r>
@@ -20620,8 +20717,8 @@
         </p:nvSpPr>
         <p:spPr>
           <a:xfrm>
-            <a:off x="10325100" y="4889500"/>
-            <a:ext cx="5194300" cy="342900"/>
+            <a:off x="10040112" y="6327648"/>
+            <a:ext cx="5468112" cy="237744"/>
           </a:xfrm>
           <a:prstGeom prst="rect">
             <a:avLst/>
@@ -20629,17 +20726,19 @@
           <a:noFill/>
         </p:spPr>
         <p:txBody>
-          <a:bodyPr vert="horz" wrap="square" lIns="0" tIns="0" rIns="0" bIns="0" rtlCol="0" anchor="t">
+          <a:bodyPr vert="horz" wrap="square" lIns="36576" tIns="0" rIns="36576" bIns="0" rtlCol="0" anchor="t">
             <a:noAutofit/>
           </a:bodyPr>
           <a:lstStyle/>
           <a:p>
             <a:r>
-              <a:rPr lang="en-US" b="1">
+              <a:rPr lang="en-US" b="1" sz="1300">
                 <a:solidFill>
                   <a:srgbClr val="203947"/>
                 </a:solidFill>
                 <a:latin typeface="Arial" panose="020B0604020202020204" pitchFamily="34" charset="0"/>
+                <a:ea typeface="Arial"/>
+                <a:cs typeface="Arial"/>
               </a:rPr>
               <a:t>Data + validation</a:t>
             </a:r>
@@ -20666,8 +20765,8 @@
         </p:nvSpPr>
         <p:spPr>
           <a:xfrm>
-            <a:off x="10325100" y="5308600"/>
-            <a:ext cx="5194300" cy="800100"/>
+            <a:off x="10040112" y="6583679"/>
+            <a:ext cx="5468112" cy="365760"/>
           </a:xfrm>
           <a:prstGeom prst="rect">
             <a:avLst/>
@@ -20675,17 +20774,19 @@
           <a:noFill/>
         </p:spPr>
         <p:txBody>
-          <a:bodyPr vert="horz" wrap="square" lIns="0" tIns="0" rIns="0" bIns="0" rtlCol="0" anchor="t">
+          <a:bodyPr vert="horz" wrap="square" lIns="36576" tIns="0" rIns="36576" bIns="0" rtlCol="0" anchor="t">
             <a:noAutofit/>
           </a:bodyPr>
           <a:lstStyle/>
           <a:p>
             <a:r>
-              <a:rPr lang="en-US" sz="1700">
+              <a:rPr lang="en-US" sz="1200">
                 <a:solidFill>
                   <a:srgbClr val="536873"/>
                 </a:solidFill>
                 <a:latin typeface="Arial" panose="020B0604020202020204" pitchFamily="34" charset="0"/>
+                <a:ea typeface="Arial"/>
+                <a:cs typeface="Arial"/>
               </a:rPr>
               <a:t>Complete 300 tickets; compare modes; Arabic default UI; fault tests; freeze configuration.</a:t>
             </a:r>
@@ -20712,8 +20813,8 @@
         </p:nvSpPr>
         <p:spPr>
           <a:xfrm>
-            <a:off x="8331200" y="6134100"/>
-            <a:ext cx="1778000" cy="406400"/>
+            <a:off x="8302752" y="7004304"/>
+            <a:ext cx="1572768" cy="310896"/>
           </a:xfrm>
           <a:prstGeom prst="rect">
             <a:avLst/>
@@ -20780,8 +20881,8 @@
         </p:nvSpPr>
         <p:spPr>
           <a:xfrm>
-            <a:off x="8432800" y="6223000"/>
-            <a:ext cx="1574800" cy="266700"/>
+            <a:off x="8339327" y="7031736"/>
+            <a:ext cx="1499616" cy="256032"/>
           </a:xfrm>
           <a:prstGeom prst="rect">
             <a:avLst/>
@@ -20789,18 +20890,20 @@
           <a:noFill/>
         </p:spPr>
         <p:txBody>
-          <a:bodyPr vert="horz" wrap="square" lIns="0" tIns="0" rIns="0" bIns="0" rtlCol="0" anchor="t">
+          <a:bodyPr vert="horz" wrap="square" lIns="36576" tIns="0" rIns="36576" bIns="0" rtlCol="0" anchor="t">
             <a:noAutofit/>
           </a:bodyPr>
           <a:lstStyle/>
           <a:p>
             <a:pPr algn="ctr"/>
             <a:r>
-              <a:rPr lang="en-US" sz="1400" b="1">
+              <a:rPr lang="en-US" sz="1100" b="1">
                 <a:solidFill>
                   <a:srgbClr val="087E83"/>
                 </a:solidFill>
                 <a:latin typeface="Arial" panose="020B0604020202020204" pitchFamily="34" charset="0"/>
+                <a:ea typeface="Arial"/>
+                <a:cs typeface="Arial"/>
               </a:rPr>
               <a:t>6-8 NOV</a:t>
             </a:r>
@@ -20827,8 +20930,8 @@
         </p:nvSpPr>
         <p:spPr>
           <a:xfrm>
-            <a:off x="10325100" y="6134100"/>
-            <a:ext cx="5194300" cy="342900"/>
+            <a:off x="10040112" y="6986016"/>
+            <a:ext cx="5468112" cy="237744"/>
           </a:xfrm>
           <a:prstGeom prst="rect">
             <a:avLst/>
@@ -20836,17 +20939,19 @@
           <a:noFill/>
         </p:spPr>
         <p:txBody>
-          <a:bodyPr vert="horz" wrap="square" lIns="0" tIns="0" rIns="0" bIns="0" rtlCol="0" anchor="t">
+          <a:bodyPr vert="horz" wrap="square" lIns="36576" tIns="0" rIns="36576" bIns="0" rtlCol="0" anchor="t">
             <a:noAutofit/>
           </a:bodyPr>
           <a:lstStyle/>
           <a:p>
             <a:r>
-              <a:rPr lang="en-US" b="1">
+              <a:rPr lang="en-US" b="1" sz="1300">
                 <a:solidFill>
                   <a:srgbClr val="203947"/>
                 </a:solidFill>
                 <a:latin typeface="Arial" panose="020B0604020202020204" pitchFamily="34" charset="0"/>
+                <a:ea typeface="Arial"/>
+                <a:cs typeface="Arial"/>
               </a:rPr>
               <a:t>Evaluate + deliver MVP</a:t>
             </a:r>
@@ -20873,8 +20978,8 @@
         </p:nvSpPr>
         <p:spPr>
           <a:xfrm>
-            <a:off x="10325100" y="6553200"/>
-            <a:ext cx="5194300" cy="800100"/>
+            <a:off x="10040112" y="7242048"/>
+            <a:ext cx="5468112" cy="365760"/>
           </a:xfrm>
           <a:prstGeom prst="rect">
             <a:avLst/>
@@ -20882,17 +20987,19 @@
           <a:noFill/>
         </p:spPr>
         <p:txBody>
-          <a:bodyPr vert="horz" wrap="square" lIns="0" tIns="0" rIns="0" bIns="0" rtlCol="0" anchor="t">
+          <a:bodyPr vert="horz" wrap="square" lIns="36576" tIns="0" rIns="36576" bIns="0" rtlCol="0" anchor="t">
             <a:noAutofit/>
           </a:bodyPr>
           <a:lstStyle/>
           <a:p>
             <a:r>
-              <a:rPr lang="en-US" sz="1700">
+              <a:rPr lang="en-US" sz="1200">
                 <a:solidFill>
                   <a:srgbClr val="536873"/>
                 </a:solidFill>
                 <a:latin typeface="Arial" panose="020B0604020202020204" pitchFamily="34" charset="0"/>
+                <a:ea typeface="Arial"/>
+                <a:cs typeface="Arial"/>
               </a:rPr>
               <a:t>Held-out run, draft scoring, cost / throughput, live rehearsal and one-page update.</a:t>
             </a:r>
@@ -21223,6 +21330,799 @@
               </a:solidFill>
               <a:latin typeface="Arial" panose="020B0604020202020204" pitchFamily="34" charset="0"/>
             </a:endParaRPr>
+          </a:p>
+        </p:txBody>
+      </p:sp>
+      <p:sp>
+        <p:nvSpPr>
+          <p:cNvPr id="44" name="test-card"/>
+          <p:cNvSpPr/>
+          <p:nvPr/>
+        </p:nvSpPr>
+        <p:spPr>
+          <a:xfrm>
+            <a:off x="512064" y="1627632"/>
+            <a:ext cx="15233904" cy="2926080"/>
+          </a:xfrm>
+          <a:prstGeom prst="rect">
+            <a:avLst/>
+          </a:prstGeom>
+          <a:solidFill>
+            <a:srgbClr val="FFFFFF"/>
+          </a:solidFill>
+          <a:ln w="12700">
+            <a:solidFill>
+              <a:srgbClr val="D9E3E7"/>
+            </a:solidFill>
+          </a:ln>
+        </p:spPr>
+        <p:style>
+          <a:lnRef idx="1">
+            <a:schemeClr val="accent1"/>
+          </a:lnRef>
+          <a:fillRef idx="3">
+            <a:schemeClr val="accent1"/>
+          </a:fillRef>
+          <a:effectRef idx="2">
+            <a:schemeClr val="accent1"/>
+          </a:effectRef>
+          <a:fontRef idx="minor">
+            <a:schemeClr val="lt1"/>
+          </a:fontRef>
+        </p:style>
+        <p:txBody>
+          <a:bodyPr rtlCol="0" anchor="ctr" wrap="none"/>
+          <a:lstStyle/>
+          <a:p>
+            <a:pPr algn="ctr"/>
+          </a:p>
+        </p:txBody>
+      </p:sp>
+      <p:sp>
+        <p:nvSpPr>
+          <p:cNvPr id="45" name="test-heading"/>
+          <p:cNvSpPr txBox="1"/>
+          <p:nvPr/>
+        </p:nvSpPr>
+        <p:spPr>
+          <a:xfrm>
+            <a:off x="676656" y="1700784"/>
+            <a:ext cx="14886432" cy="256032"/>
+          </a:xfrm>
+          <a:prstGeom prst="rect">
+            <a:avLst/>
+          </a:prstGeom>
+          <a:noFill/>
+        </p:spPr>
+        <p:txBody>
+          <a:bodyPr wrap="square" lIns="73152" rIns="73152" tIns="18288" bIns="18288" anchor="t"/>
+          <a:lstStyle/>
+          <a:p>
+            <a:pPr algn="l"/>
+            <a:r>
+              <a:rPr sz="1300" b="1">
+                <a:solidFill>
+                  <a:srgbClr val="087E83"/>
+                </a:solidFill>
+                <a:latin typeface="Arial"/>
+                <a:ea typeface="Arial"/>
+                <a:cs typeface="Arial"/>
+              </a:rPr>
+              <a:t>WHAT A GOOD RESULT LOOKS LIKE  /  HOW WE MEASURE IT</a:t>
+            </a:r>
+          </a:p>
+        </p:txBody>
+      </p:sp>
+      <p:sp>
+        <p:nvSpPr>
+          <p:cNvPr id="46" name="test-lead"/>
+          <p:cNvSpPr txBox="1"/>
+          <p:nvPr/>
+        </p:nvSpPr>
+        <p:spPr>
+          <a:xfrm>
+            <a:off x="676656" y="1956816"/>
+            <a:ext cx="14886432" cy="475488"/>
+          </a:xfrm>
+          <a:prstGeom prst="rect">
+            <a:avLst/>
+          </a:prstGeom>
+          <a:noFill/>
+        </p:spPr>
+        <p:txBody>
+          <a:bodyPr wrap="square" lIns="73152" rIns="73152" tIns="18288" bIns="18288" anchor="t"/>
+          <a:lstStyle/>
+          <a:p>
+            <a:pPr algn="l"/>
+            <a:r>
+              <a:rPr sz="1300" b="0">
+                <a:solidFill>
+                  <a:srgbClr val="203947"/>
+                </a:solidFill>
+                <a:latin typeface="Arial"/>
+                <a:ea typeface="Arial"/>
+                <a:cs typeface="Arial"/>
+              </a:rPr>
+              <a:t>Right category, team and priority — or an escalation that says why. Details that appear in the ticket. A cited Iraqi-Arabic draft that never asks for an OTP, PIN or password. A person approves, edits or rejects. Nothing is sent.</a:t>
+            </a:r>
+          </a:p>
+        </p:txBody>
+      </p:sp>
+      <p:sp>
+        <p:nvSpPr>
+          <p:cNvPr id="47" name="metric-0"/>
+          <p:cNvSpPr/>
+          <p:nvPr/>
+        </p:nvSpPr>
+        <p:spPr>
+          <a:xfrm>
+            <a:off x="713232" y="2487168"/>
+            <a:ext cx="4828032" cy="896112"/>
+          </a:xfrm>
+          <a:prstGeom prst="rect">
+            <a:avLst/>
+          </a:prstGeom>
+          <a:solidFill>
+            <a:srgbClr val="E7F3F1"/>
+          </a:solidFill>
+          <a:ln>
+            <a:noFill/>
+          </a:ln>
+        </p:spPr>
+        <p:style>
+          <a:lnRef idx="1">
+            <a:schemeClr val="accent1"/>
+          </a:lnRef>
+          <a:fillRef idx="3">
+            <a:schemeClr val="accent1"/>
+          </a:fillRef>
+          <a:effectRef idx="2">
+            <a:schemeClr val="accent1"/>
+          </a:effectRef>
+          <a:fontRef idx="minor">
+            <a:schemeClr val="lt1"/>
+          </a:fontRef>
+        </p:style>
+        <p:txBody>
+          <a:bodyPr rtlCol="0" anchor="ctr" wrap="none"/>
+          <a:lstStyle/>
+          <a:p>
+            <a:pPr algn="ctr"/>
+          </a:p>
+        </p:txBody>
+      </p:sp>
+      <p:sp>
+        <p:nvSpPr>
+          <p:cNvPr id="48" name="metric-title-0"/>
+          <p:cNvSpPr txBox="1"/>
+          <p:nvPr/>
+        </p:nvSpPr>
+        <p:spPr>
+          <a:xfrm>
+            <a:off x="786384" y="2542032"/>
+            <a:ext cx="4681728" cy="237744"/>
+          </a:xfrm>
+          <a:prstGeom prst="rect">
+            <a:avLst/>
+          </a:prstGeom>
+          <a:noFill/>
+        </p:spPr>
+        <p:txBody>
+          <a:bodyPr wrap="square" lIns="73152" rIns="73152" tIns="18288" bIns="18288" anchor="t"/>
+          <a:lstStyle/>
+          <a:p>
+            <a:pPr algn="l"/>
+            <a:r>
+              <a:rPr sz="1300" b="1">
+                <a:solidFill>
+                  <a:srgbClr val="087E83"/>
+                </a:solidFill>
+                <a:latin typeface="Arial"/>
+                <a:ea typeface="Arial"/>
+                <a:cs typeface="Arial"/>
+              </a:rPr>
+              <a:t>Classification</a:t>
+            </a:r>
+          </a:p>
+        </p:txBody>
+      </p:sp>
+      <p:sp>
+        <p:nvSpPr>
+          <p:cNvPr id="49" name="metric-body-0"/>
+          <p:cNvSpPr txBox="1"/>
+          <p:nvPr/>
+        </p:nvSpPr>
+        <p:spPr>
+          <a:xfrm>
+            <a:off x="786384" y="2779776"/>
+            <a:ext cx="4681728" cy="548640"/>
+          </a:xfrm>
+          <a:prstGeom prst="rect">
+            <a:avLst/>
+          </a:prstGeom>
+          <a:noFill/>
+        </p:spPr>
+        <p:txBody>
+          <a:bodyPr wrap="square" lIns="73152" rIns="73152" tIns="18288" bIns="18288" anchor="t"/>
+          <a:lstStyle/>
+          <a:p>
+            <a:pPr algn="l"/>
+            <a:r>
+              <a:rPr sz="1200" b="0">
+                <a:solidFill>
+                  <a:srgbClr val="203947"/>
+                </a:solidFill>
+                <a:latin typeface="Arial"/>
+                <a:ea typeface="Arial"/>
+                <a:cs typeface="Arial"/>
+              </a:rPr>
+              <a:t>Accuracy and macro-F1. Write up the top 3 confusions.</a:t>
+            </a:r>
+          </a:p>
+        </p:txBody>
+      </p:sp>
+      <p:sp>
+        <p:nvSpPr>
+          <p:cNvPr id="50" name="metric-1"/>
+          <p:cNvSpPr/>
+          <p:nvPr/>
+        </p:nvSpPr>
+        <p:spPr>
+          <a:xfrm>
+            <a:off x="5687568" y="2487168"/>
+            <a:ext cx="4828032" cy="896112"/>
+          </a:xfrm>
+          <a:prstGeom prst="rect">
+            <a:avLst/>
+          </a:prstGeom>
+          <a:solidFill>
+            <a:srgbClr val="E7F3F1"/>
+          </a:solidFill>
+          <a:ln>
+            <a:noFill/>
+          </a:ln>
+        </p:spPr>
+        <p:style>
+          <a:lnRef idx="1">
+            <a:schemeClr val="accent1"/>
+          </a:lnRef>
+          <a:fillRef idx="3">
+            <a:schemeClr val="accent1"/>
+          </a:fillRef>
+          <a:effectRef idx="2">
+            <a:schemeClr val="accent1"/>
+          </a:effectRef>
+          <a:fontRef idx="minor">
+            <a:schemeClr val="lt1"/>
+          </a:fontRef>
+        </p:style>
+        <p:txBody>
+          <a:bodyPr rtlCol="0" anchor="ctr" wrap="none"/>
+          <a:lstStyle/>
+          <a:p>
+            <a:pPr algn="ctr"/>
+          </a:p>
+        </p:txBody>
+      </p:sp>
+      <p:sp>
+        <p:nvSpPr>
+          <p:cNvPr id="51" name="metric-title-1"/>
+          <p:cNvSpPr txBox="1"/>
+          <p:nvPr/>
+        </p:nvSpPr>
+        <p:spPr>
+          <a:xfrm>
+            <a:off x="5760720" y="2542032"/>
+            <a:ext cx="4681728" cy="237744"/>
+          </a:xfrm>
+          <a:prstGeom prst="rect">
+            <a:avLst/>
+          </a:prstGeom>
+          <a:noFill/>
+        </p:spPr>
+        <p:txBody>
+          <a:bodyPr wrap="square" lIns="73152" rIns="73152" tIns="18288" bIns="18288" anchor="t"/>
+          <a:lstStyle/>
+          <a:p>
+            <a:pPr algn="l"/>
+            <a:r>
+              <a:rPr sz="1300" b="1">
+                <a:solidFill>
+                  <a:srgbClr val="087E83"/>
+                </a:solidFill>
+                <a:latin typeface="Arial"/>
+                <a:ea typeface="Arial"/>
+                <a:cs typeface="Arial"/>
+              </a:rPr>
+              <a:t>Priority and fraud</a:t>
+            </a:r>
+          </a:p>
+        </p:txBody>
+      </p:sp>
+      <p:sp>
+        <p:nvSpPr>
+          <p:cNvPr id="52" name="metric-body-1"/>
+          <p:cNvSpPr txBox="1"/>
+          <p:nvPr/>
+        </p:nvSpPr>
+        <p:spPr>
+          <a:xfrm>
+            <a:off x="5760720" y="2779776"/>
+            <a:ext cx="4681728" cy="548640"/>
+          </a:xfrm>
+          <a:prstGeom prst="rect">
+            <a:avLst/>
+          </a:prstGeom>
+          <a:noFill/>
+        </p:spPr>
+        <p:txBody>
+          <a:bodyPr wrap="square" lIns="73152" rIns="73152" tIns="18288" bIns="18288" anchor="t"/>
+          <a:lstStyle/>
+          <a:p>
+            <a:pPr algn="l"/>
+            <a:r>
+              <a:rPr sz="1200" b="0">
+                <a:solidFill>
+                  <a:srgbClr val="203947"/>
+                </a:solidFill>
+                <a:latin typeface="Arial"/>
+                <a:ea typeface="Arial"/>
+                <a:cs typeface="Arial"/>
+              </a:rPr>
+              <a:t>Exact priority, and within one level. Fraud-flag recall is the safety headline.</a:t>
+            </a:r>
+          </a:p>
+        </p:txBody>
+      </p:sp>
+      <p:sp>
+        <p:nvSpPr>
+          <p:cNvPr id="53" name="metric-2"/>
+          <p:cNvSpPr/>
+          <p:nvPr/>
+        </p:nvSpPr>
+        <p:spPr>
+          <a:xfrm>
+            <a:off x="10661904" y="2487168"/>
+            <a:ext cx="4828032" cy="896112"/>
+          </a:xfrm>
+          <a:prstGeom prst="rect">
+            <a:avLst/>
+          </a:prstGeom>
+          <a:solidFill>
+            <a:srgbClr val="E7F3F1"/>
+          </a:solidFill>
+          <a:ln>
+            <a:noFill/>
+          </a:ln>
+        </p:spPr>
+        <p:style>
+          <a:lnRef idx="1">
+            <a:schemeClr val="accent1"/>
+          </a:lnRef>
+          <a:fillRef idx="3">
+            <a:schemeClr val="accent1"/>
+          </a:fillRef>
+          <a:effectRef idx="2">
+            <a:schemeClr val="accent1"/>
+          </a:effectRef>
+          <a:fontRef idx="minor">
+            <a:schemeClr val="lt1"/>
+          </a:fontRef>
+        </p:style>
+        <p:txBody>
+          <a:bodyPr rtlCol="0" anchor="ctr" wrap="none"/>
+          <a:lstStyle/>
+          <a:p>
+            <a:pPr algn="ctr"/>
+          </a:p>
+        </p:txBody>
+      </p:sp>
+      <p:sp>
+        <p:nvSpPr>
+          <p:cNvPr id="54" name="metric-title-2"/>
+          <p:cNvSpPr txBox="1"/>
+          <p:nvPr/>
+        </p:nvSpPr>
+        <p:spPr>
+          <a:xfrm>
+            <a:off x="10735056" y="2542032"/>
+            <a:ext cx="4681728" cy="237744"/>
+          </a:xfrm>
+          <a:prstGeom prst="rect">
+            <a:avLst/>
+          </a:prstGeom>
+          <a:noFill/>
+        </p:spPr>
+        <p:txBody>
+          <a:bodyPr wrap="square" lIns="73152" rIns="73152" tIns="18288" bIns="18288" anchor="t"/>
+          <a:lstStyle/>
+          <a:p>
+            <a:pPr algn="l"/>
+            <a:r>
+              <a:rPr sz="1300" b="1">
+                <a:solidFill>
+                  <a:srgbClr val="087E83"/>
+                </a:solidFill>
+                <a:latin typeface="Arial"/>
+                <a:ea typeface="Arial"/>
+                <a:cs typeface="Arial"/>
+              </a:rPr>
+              <a:t>Extraction</a:t>
+            </a:r>
+          </a:p>
+        </p:txBody>
+      </p:sp>
+      <p:sp>
+        <p:nvSpPr>
+          <p:cNvPr id="55" name="metric-body-2"/>
+          <p:cNvSpPr txBox="1"/>
+          <p:nvPr/>
+        </p:nvSpPr>
+        <p:spPr>
+          <a:xfrm>
+            <a:off x="10735056" y="2779776"/>
+            <a:ext cx="4681728" cy="548640"/>
+          </a:xfrm>
+          <a:prstGeom prst="rect">
+            <a:avLst/>
+          </a:prstGeom>
+          <a:noFill/>
+        </p:spPr>
+        <p:txBody>
+          <a:bodyPr wrap="square" lIns="73152" rIns="73152" tIns="18288" bIns="18288" anchor="t"/>
+          <a:lstStyle/>
+          <a:p>
+            <a:pPr algn="l"/>
+            <a:r>
+              <a:rPr sz="1200" b="0">
+                <a:solidFill>
+                  <a:srgbClr val="203947"/>
+                </a:solidFill>
+                <a:latin typeface="Arial"/>
+                <a:ea typeface="Arial"/>
+                <a:cs typeface="Arial"/>
+              </a:rPr>
+              <a:t>Exact match on each field. Count invented values and missed fields.</a:t>
+            </a:r>
+          </a:p>
+        </p:txBody>
+      </p:sp>
+      <p:sp>
+        <p:nvSpPr>
+          <p:cNvPr id="56" name="metric-3"/>
+          <p:cNvSpPr/>
+          <p:nvPr/>
+        </p:nvSpPr>
+        <p:spPr>
+          <a:xfrm>
+            <a:off x="713232" y="3474720"/>
+            <a:ext cx="4828032" cy="896112"/>
+          </a:xfrm>
+          <a:prstGeom prst="rect">
+            <a:avLst/>
+          </a:prstGeom>
+          <a:solidFill>
+            <a:srgbClr val="E7F3F1"/>
+          </a:solidFill>
+          <a:ln>
+            <a:noFill/>
+          </a:ln>
+        </p:spPr>
+        <p:style>
+          <a:lnRef idx="1">
+            <a:schemeClr val="accent1"/>
+          </a:lnRef>
+          <a:fillRef idx="3">
+            <a:schemeClr val="accent1"/>
+          </a:fillRef>
+          <a:effectRef idx="2">
+            <a:schemeClr val="accent1"/>
+          </a:effectRef>
+          <a:fontRef idx="minor">
+            <a:schemeClr val="lt1"/>
+          </a:fontRef>
+        </p:style>
+        <p:txBody>
+          <a:bodyPr rtlCol="0" anchor="ctr" wrap="none"/>
+          <a:lstStyle/>
+          <a:p>
+            <a:pPr algn="ctr"/>
+          </a:p>
+        </p:txBody>
+      </p:sp>
+      <p:sp>
+        <p:nvSpPr>
+          <p:cNvPr id="57" name="metric-title-3"/>
+          <p:cNvSpPr txBox="1"/>
+          <p:nvPr/>
+        </p:nvSpPr>
+        <p:spPr>
+          <a:xfrm>
+            <a:off x="786384" y="3529584"/>
+            <a:ext cx="4681728" cy="237744"/>
+          </a:xfrm>
+          <a:prstGeom prst="rect">
+            <a:avLst/>
+          </a:prstGeom>
+          <a:noFill/>
+        </p:spPr>
+        <p:txBody>
+          <a:bodyPr wrap="square" lIns="73152" rIns="73152" tIns="18288" bIns="18288" anchor="t"/>
+          <a:lstStyle/>
+          <a:p>
+            <a:pPr algn="l"/>
+            <a:r>
+              <a:rPr sz="1300" b="1">
+                <a:solidFill>
+                  <a:srgbClr val="087E83"/>
+                </a:solidFill>
+                <a:latin typeface="Arial"/>
+                <a:ea typeface="Arial"/>
+                <a:cs typeface="Arial"/>
+              </a:rPr>
+              <a:t>Routing</a:t>
+            </a:r>
+          </a:p>
+        </p:txBody>
+      </p:sp>
+      <p:sp>
+        <p:nvSpPr>
+          <p:cNvPr id="58" name="metric-body-3"/>
+          <p:cNvSpPr txBox="1"/>
+          <p:nvPr/>
+        </p:nvSpPr>
+        <p:spPr>
+          <a:xfrm>
+            <a:off x="786384" y="3767328"/>
+            <a:ext cx="4681728" cy="548640"/>
+          </a:xfrm>
+          <a:prstGeom prst="rect">
+            <a:avLst/>
+          </a:prstGeom>
+          <a:noFill/>
+        </p:spPr>
+        <p:txBody>
+          <a:bodyPr wrap="square" lIns="73152" rIns="73152" tIns="18288" bIns="18288" anchor="t"/>
+          <a:lstStyle/>
+          <a:p>
+            <a:pPr algn="l"/>
+            <a:r>
+              <a:rPr sz="1200" b="0">
+                <a:solidFill>
+                  <a:srgbClr val="203947"/>
+                </a:solidFill>
+                <a:latin typeface="Arial"/>
+                <a:ea typeface="Arial"/>
+                <a:cs typeface="Arial"/>
+              </a:rPr>
+              <a:t>Team and lookup accuracy. Accuracy on tickets we keep, against coverage.</a:t>
+            </a:r>
+          </a:p>
+        </p:txBody>
+      </p:sp>
+      <p:sp>
+        <p:nvSpPr>
+          <p:cNvPr id="59" name="metric-4"/>
+          <p:cNvSpPr/>
+          <p:nvPr/>
+        </p:nvSpPr>
+        <p:spPr>
+          <a:xfrm>
+            <a:off x="5687568" y="3474720"/>
+            <a:ext cx="4828032" cy="896112"/>
+          </a:xfrm>
+          <a:prstGeom prst="rect">
+            <a:avLst/>
+          </a:prstGeom>
+          <a:solidFill>
+            <a:srgbClr val="E7F3F1"/>
+          </a:solidFill>
+          <a:ln>
+            <a:noFill/>
+          </a:ln>
+        </p:spPr>
+        <p:style>
+          <a:lnRef idx="1">
+            <a:schemeClr val="accent1"/>
+          </a:lnRef>
+          <a:fillRef idx="3">
+            <a:schemeClr val="accent1"/>
+          </a:fillRef>
+          <a:effectRef idx="2">
+            <a:schemeClr val="accent1"/>
+          </a:effectRef>
+          <a:fontRef idx="minor">
+            <a:schemeClr val="lt1"/>
+          </a:fontRef>
+        </p:style>
+        <p:txBody>
+          <a:bodyPr rtlCol="0" anchor="ctr" wrap="none"/>
+          <a:lstStyle/>
+          <a:p>
+            <a:pPr algn="ctr"/>
+          </a:p>
+        </p:txBody>
+      </p:sp>
+      <p:sp>
+        <p:nvSpPr>
+          <p:cNvPr id="60" name="metric-title-4"/>
+          <p:cNvSpPr txBox="1"/>
+          <p:nvPr/>
+        </p:nvSpPr>
+        <p:spPr>
+          <a:xfrm>
+            <a:off x="5760720" y="3529584"/>
+            <a:ext cx="4681728" cy="237744"/>
+          </a:xfrm>
+          <a:prstGeom prst="rect">
+            <a:avLst/>
+          </a:prstGeom>
+          <a:noFill/>
+        </p:spPr>
+        <p:txBody>
+          <a:bodyPr wrap="square" lIns="73152" rIns="73152" tIns="18288" bIns="18288" anchor="t"/>
+          <a:lstStyle/>
+          <a:p>
+            <a:pPr algn="l"/>
+            <a:r>
+              <a:rPr sz="1300" b="1">
+                <a:solidFill>
+                  <a:srgbClr val="087E83"/>
+                </a:solidFill>
+                <a:latin typeface="Arial"/>
+                <a:ea typeface="Arial"/>
+                <a:cs typeface="Arial"/>
+              </a:rPr>
+              <a:t>Draft quality</a:t>
+            </a:r>
+          </a:p>
+        </p:txBody>
+      </p:sp>
+      <p:sp>
+        <p:nvSpPr>
+          <p:cNvPr id="61" name="metric-body-4"/>
+          <p:cNvSpPr txBox="1"/>
+          <p:nvPr/>
+        </p:nvSpPr>
+        <p:spPr>
+          <a:xfrm>
+            <a:off x="5760720" y="3767328"/>
+            <a:ext cx="4681728" cy="548640"/>
+          </a:xfrm>
+          <a:prstGeom prst="rect">
+            <a:avLst/>
+          </a:prstGeom>
+          <a:noFill/>
+        </p:spPr>
+        <p:txBody>
+          <a:bodyPr wrap="square" lIns="73152" rIns="73152" tIns="18288" bIns="18288" anchor="t"/>
+          <a:lstStyle/>
+          <a:p>
+            <a:pPr algn="l"/>
+            <a:r>
+              <a:rPr sz="1200" b="0">
+                <a:solidFill>
+                  <a:srgbClr val="203947"/>
+                </a:solidFill>
+                <a:latin typeface="Arial"/>
+                <a:ea typeface="Arial"/>
+                <a:cs typeface="Arial"/>
+              </a:rPr>
+              <a:t>Guardrail pass rate and valid citations. 30 hand ratings: send with minor edits?</a:t>
+            </a:r>
+          </a:p>
+        </p:txBody>
+      </p:sp>
+      <p:sp>
+        <p:nvSpPr>
+          <p:cNvPr id="62" name="metric-5"/>
+          <p:cNvSpPr/>
+          <p:nvPr/>
+        </p:nvSpPr>
+        <p:spPr>
+          <a:xfrm>
+            <a:off x="10661904" y="3474720"/>
+            <a:ext cx="4828032" cy="896112"/>
+          </a:xfrm>
+          <a:prstGeom prst="rect">
+            <a:avLst/>
+          </a:prstGeom>
+          <a:solidFill>
+            <a:srgbClr val="E7F3F1"/>
+          </a:solidFill>
+          <a:ln>
+            <a:noFill/>
+          </a:ln>
+        </p:spPr>
+        <p:style>
+          <a:lnRef idx="1">
+            <a:schemeClr val="accent1"/>
+          </a:lnRef>
+          <a:fillRef idx="3">
+            <a:schemeClr val="accent1"/>
+          </a:fillRef>
+          <a:effectRef idx="2">
+            <a:schemeClr val="accent1"/>
+          </a:effectRef>
+          <a:fontRef idx="minor">
+            <a:schemeClr val="lt1"/>
+          </a:fontRef>
+        </p:style>
+        <p:txBody>
+          <a:bodyPr rtlCol="0" anchor="ctr" wrap="none"/>
+          <a:lstStyle/>
+          <a:p>
+            <a:pPr algn="ctr"/>
+          </a:p>
+        </p:txBody>
+      </p:sp>
+      <p:sp>
+        <p:nvSpPr>
+          <p:cNvPr id="63" name="metric-title-5"/>
+          <p:cNvSpPr txBox="1"/>
+          <p:nvPr/>
+        </p:nvSpPr>
+        <p:spPr>
+          <a:xfrm>
+            <a:off x="10735056" y="3529584"/>
+            <a:ext cx="4681728" cy="237744"/>
+          </a:xfrm>
+          <a:prstGeom prst="rect">
+            <a:avLst/>
+          </a:prstGeom>
+          <a:noFill/>
+        </p:spPr>
+        <p:txBody>
+          <a:bodyPr wrap="square" lIns="73152" rIns="73152" tIns="18288" bIns="18288" anchor="t"/>
+          <a:lstStyle/>
+          <a:p>
+            <a:pPr algn="l"/>
+            <a:r>
+              <a:rPr sz="1300" b="1">
+                <a:solidFill>
+                  <a:srgbClr val="087E83"/>
+                </a:solidFill>
+                <a:latin typeface="Arial"/>
+                <a:ea typeface="Arial"/>
+                <a:cs typeface="Arial"/>
+              </a:rPr>
+              <a:t>Protected test</a:t>
+            </a:r>
+          </a:p>
+        </p:txBody>
+      </p:sp>
+      <p:sp>
+        <p:nvSpPr>
+          <p:cNvPr id="64" name="metric-body-5"/>
+          <p:cNvSpPr txBox="1"/>
+          <p:nvPr/>
+        </p:nvSpPr>
+        <p:spPr>
+          <a:xfrm>
+            <a:off x="10735056" y="3767328"/>
+            <a:ext cx="4681728" cy="548640"/>
+          </a:xfrm>
+          <a:prstGeom prst="rect">
+            <a:avLst/>
+          </a:prstGeom>
+          <a:noFill/>
+        </p:spPr>
+        <p:txBody>
+          <a:bodyPr wrap="square" lIns="73152" rIns="73152" tIns="18288" bIns="18288" anchor="t"/>
+          <a:lstStyle/>
+          <a:p>
+            <a:pPr algn="l"/>
+            <a:r>
+              <a:rPr sz="1200" b="0">
+                <a:solidFill>
+                  <a:srgbClr val="203947"/>
+                </a:solidFill>
+                <a:latin typeface="Arial"/>
+                <a:ea typeface="Arial"/>
+                <a:cs typeface="Arial"/>
+              </a:rPr>
+              <a:t>Tune on 200. Hold out 100. Commit the hash first. One run: Jev, Gemini, cascade.</a:t>
+            </a:r>
           </a:p>
         </p:txBody>
       </p:sp>

</xml_diff>

<commit_message>
refactor: reorganize imports across multiple files for improved readability and maintainability; remove unused presentation scripts
</commit_message>
<xml_diff>
--- a/presentation/SaifAlmaliki_Topic06_FAZAA_Design_Brief.pptx
+++ b/presentation/SaifAlmaliki_Topic06_FAZAA_Design_Brief.pptx
@@ -1462,7 +1462,9 @@
               <a:t>These checks validate the presentation artifact, not model availability, application test results, production readiness or real-world customer impact.</a:t>
             </a:r>
           </a:p>
-          <a:p/>
+          <a:p>
+            <a:endParaRPr/>
+          </a:p>
           <a:p>
             <a:r>
               <a:t>EVALUATION PLAN added 18 October 2026 (design spec section 7). This is the measurement plan, not a result.</a:t>
@@ -1498,7 +1500,9 @@
               <a:t>Risks, the week-by-week plan and the GitHub link were already on this slide. The link is https://github.com/SaifAlmaliki/zaincash-customer-support-agent</a:t>
             </a:r>
           </a:p>
-          <a:p/>
+          <a:p>
+            <a:endParaRPr/>
+          </a:p>
         </p:txBody>
       </p:sp>
       <p:sp>
@@ -11525,15 +11529,15 @@
           <a:lstStyle/>
           <a:p>
             <a:r>
-              <a:rPr lang="en-US" sz="1400" b="1">
+              <a:rPr lang="en-US" sz="1400" b="1" dirty="0">
                 <a:solidFill>
                   <a:srgbClr val="536873"/>
                 </a:solidFill>
                 <a:latin typeface="Arial" panose="020B0604020202020204" pitchFamily="34" charset="0"/>
               </a:rPr>
-              <a:t>PLANNED / RAG DRAFTING</a:t>
-            </a:r>
-            <a:endParaRPr lang="en-DE" sz="1400" b="1">
+              <a:t>RAG DRAFTING</a:t>
+            </a:r>
+            <a:endParaRPr lang="en-DE" sz="1400" b="1" dirty="0">
               <a:solidFill>
                 <a:srgbClr val="536873"/>
               </a:solidFill>
@@ -12212,6 +12216,37 @@
           <a:xfrm>
             <a:off x="4718739" y="5812115"/>
             <a:ext cx="833507" cy="307790"/>
+          </a:xfrm>
+          <a:prstGeom prst="rect">
+            <a:avLst/>
+          </a:prstGeom>
+        </p:spPr>
+      </p:pic>
+      <p:pic>
+        <p:nvPicPr>
+          <p:cNvPr id="56" name="Picture 55" descr="RAG-Symbol, Retrieval-Augmented Generation, Liniendesign auf Weiß:  Stock-Vektorgrafik (Lizenzfrei) 2694316729 | Shutterstock">
+            <a:extLst>
+              <a:ext uri="{FF2B5EF4-FFF2-40B4-BE49-F238E27FC236}">
+                <a16:creationId xmlns:a16="http://schemas.microsoft.com/office/drawing/2014/main" id="{87AC86FE-1EC6-4E1F-0094-608A8F0C5742}"/>
+              </a:ext>
+            </a:extLst>
+          </p:cNvPr>
+          <p:cNvPicPr>
+            <a:picLocks noChangeAspect="1"/>
+          </p:cNvPicPr>
+          <p:nvPr/>
+        </p:nvPicPr>
+        <p:blipFill>
+          <a:blip r:embed="rId8"/>
+          <a:srcRect l="19231" t="13334" r="21282" b="25238"/>
+          <a:stretch>
+            <a:fillRect/>
+          </a:stretch>
+        </p:blipFill>
+        <p:spPr>
+          <a:xfrm>
+            <a:off x="15043150" y="6040656"/>
+            <a:ext cx="647700" cy="720287"/>
           </a:xfrm>
           <a:prstGeom prst="rect">
             <a:avLst/>
@@ -19607,7 +19642,7 @@
           <a:lstStyle/>
           <a:p>
             <a:r>
-              <a:rPr lang="en-US" b="1" sz="1300">
+              <a:rPr lang="en-US" sz="1300" b="1">
                 <a:solidFill>
                   <a:srgbClr val="203947"/>
                 </a:solidFill>
@@ -19703,7 +19738,7 @@
           <a:lstStyle/>
           <a:p>
             <a:r>
-              <a:rPr lang="en-US" b="1" sz="1300">
+              <a:rPr lang="en-US" sz="1300" b="1">
                 <a:solidFill>
                   <a:srgbClr val="203947"/>
                 </a:solidFill>
@@ -19799,7 +19834,7 @@
           <a:lstStyle/>
           <a:p>
             <a:r>
-              <a:rPr lang="en-US" b="1" sz="1300">
+              <a:rPr lang="en-US" sz="1300" b="1">
                 <a:solidFill>
                   <a:srgbClr val="203947"/>
                 </a:solidFill>
@@ -19895,7 +19930,7 @@
           <a:lstStyle/>
           <a:p>
             <a:r>
-              <a:rPr lang="en-US" b="1" sz="1300">
+              <a:rPr lang="en-US" sz="1300" b="1">
                 <a:solidFill>
                   <a:srgbClr val="203947"/>
                 </a:solidFill>
@@ -19991,7 +20026,7 @@
           <a:lstStyle/>
           <a:p>
             <a:r>
-              <a:rPr lang="en-US" b="1" sz="1300">
+              <a:rPr lang="en-US" sz="1300" b="1">
                 <a:solidFill>
                   <a:srgbClr val="203947"/>
                 </a:solidFill>
@@ -20306,7 +20341,7 @@
           <a:lstStyle/>
           <a:p>
             <a:r>
-              <a:rPr lang="en-US" b="1" sz="1300">
+              <a:rPr lang="en-US" sz="1300" b="1">
                 <a:solidFill>
                   <a:srgbClr val="203947"/>
                 </a:solidFill>
@@ -20519,7 +20554,7 @@
           <a:lstStyle/>
           <a:p>
             <a:r>
-              <a:rPr lang="en-US" b="1" sz="1300">
+              <a:rPr lang="en-US" sz="1300" b="1">
                 <a:solidFill>
                   <a:srgbClr val="203947"/>
                 </a:solidFill>
@@ -20732,7 +20767,7 @@
           <a:lstStyle/>
           <a:p>
             <a:r>
-              <a:rPr lang="en-US" b="1" sz="1300">
+              <a:rPr lang="en-US" sz="1300" b="1">
                 <a:solidFill>
                   <a:srgbClr val="203947"/>
                 </a:solidFill>
@@ -20945,7 +20980,7 @@
           <a:lstStyle/>
           <a:p>
             <a:r>
-              <a:rPr lang="en-US" b="1" sz="1300">
+              <a:rPr lang="en-US" sz="1300" b="1">
                 <a:solidFill>
                   <a:srgbClr val="203947"/>
                 </a:solidFill>
@@ -21371,10 +21406,11 @@
           </a:fontRef>
         </p:style>
         <p:txBody>
-          <a:bodyPr rtlCol="0" anchor="ctr" wrap="none"/>
+          <a:bodyPr wrap="none" rtlCol="0" anchor="ctr"/>
           <a:lstStyle/>
           <a:p>
             <a:pPr algn="ctr"/>
+            <a:endParaRPr/>
           </a:p>
         </p:txBody>
       </p:sp>
@@ -21395,7 +21431,7 @@
           <a:noFill/>
         </p:spPr>
         <p:txBody>
-          <a:bodyPr wrap="square" lIns="73152" rIns="73152" tIns="18288" bIns="18288" anchor="t"/>
+          <a:bodyPr wrap="square" lIns="73152" tIns="18288" rIns="73152" bIns="18288" anchor="t"/>
           <a:lstStyle/>
           <a:p>
             <a:pPr algn="l"/>
@@ -21430,7 +21466,7 @@
           <a:noFill/>
         </p:spPr>
         <p:txBody>
-          <a:bodyPr wrap="square" lIns="73152" rIns="73152" tIns="18288" bIns="18288" anchor="t"/>
+          <a:bodyPr wrap="square" lIns="73152" tIns="18288" rIns="73152" bIns="18288" anchor="t"/>
           <a:lstStyle/>
           <a:p>
             <a:pPr algn="l"/>
@@ -21484,10 +21520,11 @@
           </a:fontRef>
         </p:style>
         <p:txBody>
-          <a:bodyPr rtlCol="0" anchor="ctr" wrap="none"/>
+          <a:bodyPr wrap="none" rtlCol="0" anchor="ctr"/>
           <a:lstStyle/>
           <a:p>
             <a:pPr algn="ctr"/>
+            <a:endParaRPr/>
           </a:p>
         </p:txBody>
       </p:sp>
@@ -21508,7 +21545,7 @@
           <a:noFill/>
         </p:spPr>
         <p:txBody>
-          <a:bodyPr wrap="square" lIns="73152" rIns="73152" tIns="18288" bIns="18288" anchor="t"/>
+          <a:bodyPr wrap="square" lIns="73152" tIns="18288" rIns="73152" bIns="18288" anchor="t"/>
           <a:lstStyle/>
           <a:p>
             <a:pPr algn="l"/>
@@ -21543,7 +21580,7 @@
           <a:noFill/>
         </p:spPr>
         <p:txBody>
-          <a:bodyPr wrap="square" lIns="73152" rIns="73152" tIns="18288" bIns="18288" anchor="t"/>
+          <a:bodyPr wrap="square" lIns="73152" tIns="18288" rIns="73152" bIns="18288" anchor="t"/>
           <a:lstStyle/>
           <a:p>
             <a:pPr algn="l"/>
@@ -21597,10 +21634,11 @@
           </a:fontRef>
         </p:style>
         <p:txBody>
-          <a:bodyPr rtlCol="0" anchor="ctr" wrap="none"/>
+          <a:bodyPr wrap="none" rtlCol="0" anchor="ctr"/>
           <a:lstStyle/>
           <a:p>
             <a:pPr algn="ctr"/>
+            <a:endParaRPr/>
           </a:p>
         </p:txBody>
       </p:sp>
@@ -21621,7 +21659,7 @@
           <a:noFill/>
         </p:spPr>
         <p:txBody>
-          <a:bodyPr wrap="square" lIns="73152" rIns="73152" tIns="18288" bIns="18288" anchor="t"/>
+          <a:bodyPr wrap="square" lIns="73152" tIns="18288" rIns="73152" bIns="18288" anchor="t"/>
           <a:lstStyle/>
           <a:p>
             <a:pPr algn="l"/>
@@ -21656,7 +21694,7 @@
           <a:noFill/>
         </p:spPr>
         <p:txBody>
-          <a:bodyPr wrap="square" lIns="73152" rIns="73152" tIns="18288" bIns="18288" anchor="t"/>
+          <a:bodyPr wrap="square" lIns="73152" tIns="18288" rIns="73152" bIns="18288" anchor="t"/>
           <a:lstStyle/>
           <a:p>
             <a:pPr algn="l"/>
@@ -21710,10 +21748,11 @@
           </a:fontRef>
         </p:style>
         <p:txBody>
-          <a:bodyPr rtlCol="0" anchor="ctr" wrap="none"/>
+          <a:bodyPr wrap="none" rtlCol="0" anchor="ctr"/>
           <a:lstStyle/>
           <a:p>
             <a:pPr algn="ctr"/>
+            <a:endParaRPr/>
           </a:p>
         </p:txBody>
       </p:sp>
@@ -21734,7 +21773,7 @@
           <a:noFill/>
         </p:spPr>
         <p:txBody>
-          <a:bodyPr wrap="square" lIns="73152" rIns="73152" tIns="18288" bIns="18288" anchor="t"/>
+          <a:bodyPr wrap="square" lIns="73152" tIns="18288" rIns="73152" bIns="18288" anchor="t"/>
           <a:lstStyle/>
           <a:p>
             <a:pPr algn="l"/>
@@ -21769,7 +21808,7 @@
           <a:noFill/>
         </p:spPr>
         <p:txBody>
-          <a:bodyPr wrap="square" lIns="73152" rIns="73152" tIns="18288" bIns="18288" anchor="t"/>
+          <a:bodyPr wrap="square" lIns="73152" tIns="18288" rIns="73152" bIns="18288" anchor="t"/>
           <a:lstStyle/>
           <a:p>
             <a:pPr algn="l"/>
@@ -21823,10 +21862,11 @@
           </a:fontRef>
         </p:style>
         <p:txBody>
-          <a:bodyPr rtlCol="0" anchor="ctr" wrap="none"/>
+          <a:bodyPr wrap="none" rtlCol="0" anchor="ctr"/>
           <a:lstStyle/>
           <a:p>
             <a:pPr algn="ctr"/>
+            <a:endParaRPr/>
           </a:p>
         </p:txBody>
       </p:sp>
@@ -21847,7 +21887,7 @@
           <a:noFill/>
         </p:spPr>
         <p:txBody>
-          <a:bodyPr wrap="square" lIns="73152" rIns="73152" tIns="18288" bIns="18288" anchor="t"/>
+          <a:bodyPr wrap="square" lIns="73152" tIns="18288" rIns="73152" bIns="18288" anchor="t"/>
           <a:lstStyle/>
           <a:p>
             <a:pPr algn="l"/>
@@ -21882,7 +21922,7 @@
           <a:noFill/>
         </p:spPr>
         <p:txBody>
-          <a:bodyPr wrap="square" lIns="73152" rIns="73152" tIns="18288" bIns="18288" anchor="t"/>
+          <a:bodyPr wrap="square" lIns="73152" tIns="18288" rIns="73152" bIns="18288" anchor="t"/>
           <a:lstStyle/>
           <a:p>
             <a:pPr algn="l"/>
@@ -21936,10 +21976,11 @@
           </a:fontRef>
         </p:style>
         <p:txBody>
-          <a:bodyPr rtlCol="0" anchor="ctr" wrap="none"/>
+          <a:bodyPr wrap="none" rtlCol="0" anchor="ctr"/>
           <a:lstStyle/>
           <a:p>
             <a:pPr algn="ctr"/>
+            <a:endParaRPr/>
           </a:p>
         </p:txBody>
       </p:sp>
@@ -21960,7 +22001,7 @@
           <a:noFill/>
         </p:spPr>
         <p:txBody>
-          <a:bodyPr wrap="square" lIns="73152" rIns="73152" tIns="18288" bIns="18288" anchor="t"/>
+          <a:bodyPr wrap="square" lIns="73152" tIns="18288" rIns="73152" bIns="18288" anchor="t"/>
           <a:lstStyle/>
           <a:p>
             <a:pPr algn="l"/>
@@ -21995,7 +22036,7 @@
           <a:noFill/>
         </p:spPr>
         <p:txBody>
-          <a:bodyPr wrap="square" lIns="73152" rIns="73152" tIns="18288" bIns="18288" anchor="t"/>
+          <a:bodyPr wrap="square" lIns="73152" tIns="18288" rIns="73152" bIns="18288" anchor="t"/>
           <a:lstStyle/>
           <a:p>
             <a:pPr algn="l"/>
@@ -22049,10 +22090,11 @@
           </a:fontRef>
         </p:style>
         <p:txBody>
-          <a:bodyPr rtlCol="0" anchor="ctr" wrap="none"/>
+          <a:bodyPr wrap="none" rtlCol="0" anchor="ctr"/>
           <a:lstStyle/>
           <a:p>
             <a:pPr algn="ctr"/>
+            <a:endParaRPr/>
           </a:p>
         </p:txBody>
       </p:sp>
@@ -22073,7 +22115,7 @@
           <a:noFill/>
         </p:spPr>
         <p:txBody>
-          <a:bodyPr wrap="square" lIns="73152" rIns="73152" tIns="18288" bIns="18288" anchor="t"/>
+          <a:bodyPr wrap="square" lIns="73152" tIns="18288" rIns="73152" bIns="18288" anchor="t"/>
           <a:lstStyle/>
           <a:p>
             <a:pPr algn="l"/>
@@ -22108,7 +22150,7 @@
           <a:noFill/>
         </p:spPr>
         <p:txBody>
-          <a:bodyPr wrap="square" lIns="73152" rIns="73152" tIns="18288" bIns="18288" anchor="t"/>
+          <a:bodyPr wrap="square" lIns="73152" tIns="18288" rIns="73152" bIns="18288" anchor="t"/>
           <a:lstStyle/>
           <a:p>
             <a:pPr algn="l"/>

</xml_diff>